<commit_message>
ppt added and ipyb added
</commit_message>
<xml_diff>
--- a/ML Capstone project/Project PPT/HR_Attrition_Prediction_Presentation.pptx
+++ b/ML Capstone project/Project PPT/HR_Attrition_Prediction_Presentation.pptx
@@ -124,6 +124,7 @@
 <file path=ppt/revisionInfo.xml><?xml version="1.0" encoding="utf-8"?>
 <p1510:revInfo xmlns:a="http://schemas.openxmlformats.org/drawingml/2006/main" xmlns:r="http://schemas.openxmlformats.org/officeDocument/2006/relationships" xmlns:p1510="http://schemas.microsoft.com/office/powerpoint/2015/10/main">
   <p1510:revLst>
+    <p1510:client id="{74588D86-496A-4600-BFAB-20AAC775E931}" v="6" dt="2026-08-03T15:51:19.967"/>
     <p1510:client id="{F456945F-80F7-47A9-A532-46BFEB4CECF1}" v="3" dt="2026-08-03T07:28:49.910"/>
   </p1510:revLst>
 </p1510:revInfo>
@@ -397,6 +398,30 @@
           <pc:docMk/>
           <pc:sldMk cId="1505222531" sldId="267"/>
         </pc:sldMkLst>
+      </pc:sldChg>
+    </pc:docChg>
+  </pc:docChgLst>
+  <pc:docChgLst>
+    <pc:chgData name="Deeksha Yadav" userId="d5c5f35da958ad8b" providerId="LiveId" clId="{9DEC21A7-9734-40EC-B46F-A8C60F5D013E}"/>
+    <pc:docChg chg="undo custSel modSld">
+      <pc:chgData name="Deeksha Yadav" userId="d5c5f35da958ad8b" providerId="LiveId" clId="{9DEC21A7-9734-40EC-B46F-A8C60F5D013E}" dt="2026-08-03T15:51:19.967" v="54"/>
+      <pc:docMkLst>
+        <pc:docMk/>
+      </pc:docMkLst>
+      <pc:sldChg chg="modSp mod">
+        <pc:chgData name="Deeksha Yadav" userId="d5c5f35da958ad8b" providerId="LiveId" clId="{9DEC21A7-9734-40EC-B46F-A8C60F5D013E}" dt="2026-08-03T15:51:19.967" v="54"/>
+        <pc:sldMkLst>
+          <pc:docMk/>
+          <pc:sldMk cId="3596593333" sldId="263"/>
+        </pc:sldMkLst>
+        <pc:spChg chg="mod">
+          <ac:chgData name="Deeksha Yadav" userId="d5c5f35da958ad8b" providerId="LiveId" clId="{9DEC21A7-9734-40EC-B46F-A8C60F5D013E}" dt="2026-08-03T15:51:19.967" v="54"/>
+          <ac:spMkLst>
+            <pc:docMk/>
+            <pc:sldMk cId="3596593333" sldId="263"/>
+            <ac:spMk id="3" creationId="{A119DBF1-ACDD-D2D6-7692-C38932B7D85B}"/>
+          </ac:spMkLst>
+        </pc:spChg>
       </pc:sldChg>
     </pc:docChg>
   </pc:docChgLst>
@@ -7605,8 +7630,8 @@
               <a:t>  Model Comparison (on Test Set after Hyperparameter Tuning):
   Model                  		Accuracy    	Precision   	Recall   		F1-Score
   ─────────────────────────────────────────────────────────────
-  Logistic Regression ★  	0.77       		0.38       		 0.68     		0.48  ← BEST
-  Random Forest          	0.83      		0.48        		0.47     		0.47
+  Logistic Regression ★ 	0.76       		0.37       		0.68     		0.48  ← BEST
+  Random Forest 		0.83      		0.48        		0.47     		0.47
   Decision Tree          	0.77       		0.35        		0.53     		0.42
   Naive Bayes            	0.62       		0.25        		0.70     		0.37
   KNN                    		0.82       		0.31        		0.11     		0.16

</xml_diff>